<commit_message>
Intern Presentation updated(Tools & Techs images added)
</commit_message>
<xml_diff>
--- a/docs/Intern-Presentation/200112-Internship-presentation.pptx
+++ b/docs/Intern-Presentation/200112-Internship-presentation.pptx
@@ -11015,6 +11015,136 @@
           </a:p>
         </p:txBody>
       </p:sp>
+      <p:pic>
+        <p:nvPicPr>
+          <p:cNvPr id="7" name="Image 0" descr="images/next_js.png">
+            <a:extLst>
+              <a:ext uri="{FF2B5EF4-FFF2-40B4-BE49-F238E27FC236}">
+                <a16:creationId xmlns:a16="http://schemas.microsoft.com/office/drawing/2014/main" id="{D8A02BEE-C7E3-5F7D-6628-7CFC27881328}"/>
+              </a:ext>
+            </a:extLst>
+          </p:cNvPr>
+          <p:cNvPicPr>
+            <a:picLocks noChangeAspect="1"/>
+          </p:cNvPicPr>
+          <p:nvPr/>
+        </p:nvPicPr>
+        <p:blipFill>
+          <a:blip r:embed="rId3"/>
+          <a:srcRect/>
+          <a:stretch/>
+        </p:blipFill>
+        <p:spPr>
+          <a:xfrm>
+            <a:off x="3917968" y="2408329"/>
+            <a:ext cx="914400" cy="914400"/>
+          </a:xfrm>
+          <a:prstGeom prst="rect">
+            <a:avLst/>
+          </a:prstGeom>
+        </p:spPr>
+      </p:pic>
+      <p:pic>
+        <p:nvPicPr>
+          <p:cNvPr id="8" name="Image 1" descr="images/node_js.png">
+            <a:extLst>
+              <a:ext uri="{FF2B5EF4-FFF2-40B4-BE49-F238E27FC236}">
+                <a16:creationId xmlns:a16="http://schemas.microsoft.com/office/drawing/2014/main" id="{7AD2DA9E-8F33-61EA-833C-8C9E6AD60357}"/>
+              </a:ext>
+            </a:extLst>
+          </p:cNvPr>
+          <p:cNvPicPr>
+            <a:picLocks noChangeAspect="1"/>
+          </p:cNvPicPr>
+          <p:nvPr/>
+        </p:nvPicPr>
+        <p:blipFill>
+          <a:blip r:embed="rId4"/>
+          <a:srcRect/>
+          <a:stretch/>
+        </p:blipFill>
+        <p:spPr>
+          <a:xfrm>
+            <a:off x="9726168" y="2408329"/>
+            <a:ext cx="914400" cy="914400"/>
+          </a:xfrm>
+          <a:prstGeom prst="rect">
+            <a:avLst/>
+          </a:prstGeom>
+        </p:spPr>
+      </p:pic>
+      <p:pic>
+        <p:nvPicPr>
+          <p:cNvPr id="16" name="Picture 15" descr="A white snake with a black background&#10;&#10;AI-generated content may be incorrect.">
+            <a:extLst>
+              <a:ext uri="{FF2B5EF4-FFF2-40B4-BE49-F238E27FC236}">
+                <a16:creationId xmlns:a16="http://schemas.microsoft.com/office/drawing/2014/main" id="{39C6CA37-76D0-1531-47FD-465A8BCF350B}"/>
+              </a:ext>
+            </a:extLst>
+          </p:cNvPr>
+          <p:cNvPicPr>
+            <a:picLocks noChangeAspect="1"/>
+          </p:cNvPicPr>
+          <p:nvPr/>
+        </p:nvPicPr>
+        <p:blipFill>
+          <a:blip r:embed="rId5" cstate="print">
+            <a:extLst>
+              <a:ext uri="{28A0092B-C50C-407E-A947-70E740481C1C}">
+                <a14:useLocalDpi xmlns:a14="http://schemas.microsoft.com/office/drawing/2010/main" val="0"/>
+              </a:ext>
+            </a:extLst>
+          </a:blip>
+          <a:stretch>
+            <a:fillRect/>
+          </a:stretch>
+        </p:blipFill>
+        <p:spPr>
+          <a:xfrm>
+            <a:off x="7585855" y="4621700"/>
+            <a:ext cx="3055466" cy="940900"/>
+          </a:xfrm>
+          <a:prstGeom prst="rect">
+            <a:avLst/>
+          </a:prstGeom>
+        </p:spPr>
+      </p:pic>
+      <p:pic>
+        <p:nvPicPr>
+          <p:cNvPr id="18" name="Picture 17" descr="A group of arrows with a blue arch&#10;&#10;AI-generated content may be incorrect.">
+            <a:extLst>
+              <a:ext uri="{FF2B5EF4-FFF2-40B4-BE49-F238E27FC236}">
+                <a16:creationId xmlns:a16="http://schemas.microsoft.com/office/drawing/2014/main" id="{5D903E16-8CDC-67F6-A39F-D2A93892ECDD}"/>
+              </a:ext>
+            </a:extLst>
+          </p:cNvPr>
+          <p:cNvPicPr>
+            <a:picLocks noChangeAspect="1"/>
+          </p:cNvPicPr>
+          <p:nvPr/>
+        </p:nvPicPr>
+        <p:blipFill>
+          <a:blip r:embed="rId6" cstate="print">
+            <a:extLst>
+              <a:ext uri="{28A0092B-C50C-407E-A947-70E740481C1C}">
+                <a14:useLocalDpi xmlns:a14="http://schemas.microsoft.com/office/drawing/2010/main" val="0"/>
+              </a:ext>
+            </a:extLst>
+          </a:blip>
+          <a:stretch>
+            <a:fillRect/>
+          </a:stretch>
+        </p:blipFill>
+        <p:spPr>
+          <a:xfrm>
+            <a:off x="679531" y="4303777"/>
+            <a:ext cx="1588710" cy="1042723"/>
+          </a:xfrm>
+          <a:prstGeom prst="rect">
+            <a:avLst/>
+          </a:prstGeom>
+        </p:spPr>
+      </p:pic>
     </p:spTree>
     <p:extLst>
       <p:ext uri="{BB962C8B-B14F-4D97-AF65-F5344CB8AC3E}">

</xml_diff>

<commit_message>
Office Logo added in the presentation
</commit_message>
<xml_diff>
--- a/docs/Intern-Presentation/200112-Internship-presentation.pptx
+++ b/docs/Intern-Presentation/200112-Internship-presentation.pptx
@@ -9160,6 +9160,42 @@
           <a:xfrm>
             <a:off x="7450552" y="618383"/>
             <a:ext cx="4876190" cy="4876190"/>
+          </a:xfrm>
+          <a:prstGeom prst="rect">
+            <a:avLst/>
+          </a:prstGeom>
+        </p:spPr>
+      </p:pic>
+      <p:pic>
+        <p:nvPicPr>
+          <p:cNvPr id="14" name="Picture 13" descr="A group of blue and white logos&#10;&#10;AI-generated content may be incorrect.">
+            <a:extLst>
+              <a:ext uri="{FF2B5EF4-FFF2-40B4-BE49-F238E27FC236}">
+                <a16:creationId xmlns:a16="http://schemas.microsoft.com/office/drawing/2014/main" id="{DF26BF62-765D-F758-6483-5DD4875D39DD}"/>
+              </a:ext>
+            </a:extLst>
+          </p:cNvPr>
+          <p:cNvPicPr>
+            <a:picLocks noChangeAspect="1"/>
+          </p:cNvPicPr>
+          <p:nvPr/>
+        </p:nvPicPr>
+        <p:blipFill>
+          <a:blip r:embed="rId4">
+            <a:extLst>
+              <a:ext uri="{28A0092B-C50C-407E-A947-70E740481C1C}">
+                <a14:useLocalDpi xmlns:a14="http://schemas.microsoft.com/office/drawing/2010/main" val="0"/>
+              </a:ext>
+            </a:extLst>
+          </a:blip>
+          <a:stretch>
+            <a:fillRect/>
+          </a:stretch>
+        </p:blipFill>
+        <p:spPr>
+          <a:xfrm>
+            <a:off x="2447761" y="5273006"/>
+            <a:ext cx="6439799" cy="1143160"/>
           </a:xfrm>
           <a:prstGeom prst="rect">
             <a:avLst/>

</xml_diff>